<commit_message>
Update menu assets for Regular and Tournament menus
</commit_message>
<xml_diff>
--- a/Assets/Menu/TournamentMenu/TournamentMenu.pptx
+++ b/Assets/Menu/TournamentMenu/TournamentMenu.pptx
@@ -11114,7 +11114,7 @@
                 <a:cs typeface="Calibri"/>
                 <a:sym typeface="Calibri"/>
               </a:rPr>
-              <a:t>Nachos w/ Cheese</a:t>
+              <a:t>Nachos</a:t>
             </a:r>
           </a:p>
           <a:p>
@@ -11222,20 +11222,14 @@
           </a:p>
           <a:p>
             <a:r>
-              <a:rPr lang="en-US" sz="2700" b="1" dirty="0" err="1">
+              <a:rPr lang="en-US" sz="2700" b="1" dirty="0">
                 <a:latin typeface="Calibri"/>
                 <a:ea typeface="Calibri"/>
                 <a:cs typeface="Calibri"/>
                 <a:sym typeface="Calibri"/>
               </a:rPr>
-              <a:t>Icee</a:t>
+              <a:t>Fla-Vor-Ice</a:t>
             </a:r>
-            <a:endParaRPr lang="en-US" sz="2700" b="1" dirty="0">
-              <a:latin typeface="Calibri"/>
-              <a:ea typeface="Calibri"/>
-              <a:cs typeface="Calibri"/>
-              <a:sym typeface="Calibri"/>
-            </a:endParaRPr>
           </a:p>
         </p:txBody>
       </p:sp>
@@ -11308,7 +11302,7 @@
         <p:spPr>
           <a:xfrm>
             <a:off x="12216861" y="3865157"/>
-            <a:ext cx="2794273" cy="1762680"/>
+            <a:ext cx="2794273" cy="1938948"/>
           </a:xfrm>
           <a:prstGeom prst="rect">
             <a:avLst/>
@@ -11331,7 +11325,7 @@
                 <a:cs typeface="Calibri"/>
                 <a:sym typeface="Calibri"/>
               </a:rPr>
-              <a:t>Chips</a:t>
+              <a:t>Candy</a:t>
             </a:r>
           </a:p>
           <a:p>
@@ -11342,7 +11336,7 @@
                 <a:cs typeface="Calibri"/>
                 <a:sym typeface="Calibri"/>
               </a:rPr>
-              <a:t>Candy</a:t>
+              <a:t>Chips</a:t>
             </a:r>
           </a:p>
           <a:p>
@@ -11407,6 +11401,17 @@
                 <a:cs typeface="Calibri"/>
                 <a:sym typeface="Calibri"/>
               </a:rPr>
+              <a:t>Gatorade </a:t>
+            </a:r>
+          </a:p>
+          <a:p>
+            <a:r>
+              <a:rPr lang="en-US" sz="2700" b="1" dirty="0">
+                <a:latin typeface="Calibri"/>
+                <a:ea typeface="Calibri"/>
+                <a:cs typeface="Calibri"/>
+                <a:sym typeface="Calibri"/>
+              </a:rPr>
               <a:t>Water</a:t>
             </a:r>
           </a:p>
@@ -11419,17 +11424,6 @@
                 <a:sym typeface="Calibri"/>
               </a:rPr>
               <a:t>Pop</a:t>
-            </a:r>
-          </a:p>
-          <a:p>
-            <a:r>
-              <a:rPr lang="en-US" sz="2700" b="1" dirty="0">
-                <a:latin typeface="Calibri"/>
-                <a:ea typeface="Calibri"/>
-                <a:cs typeface="Calibri"/>
-                <a:sym typeface="Calibri"/>
-              </a:rPr>
-              <a:t>Gatorade</a:t>
             </a:r>
           </a:p>
           <a:p>
@@ -11668,7 +11662,7 @@
                 <a:cs typeface="Calibri"/>
                 <a:sym typeface="Calibri"/>
               </a:rPr>
-              <a:t>$2.00</a:t>
+              <a:t>$2.50</a:t>
             </a:r>
           </a:p>
           <a:p>
@@ -11754,7 +11748,7 @@
                 <a:cs typeface="Calibri"/>
                 <a:sym typeface="Calibri"/>
               </a:rPr>
-              <a:t>$1.00 - $3.00</a:t>
+              <a:t>$3.00</a:t>
             </a:r>
             <a:endParaRPr sz="2700" b="1" dirty="0">
               <a:latin typeface="Calibri"/>
@@ -11798,7 +11792,7 @@
         <p:spPr>
           <a:xfrm>
             <a:off x="16715018" y="3875315"/>
-            <a:ext cx="1122694" cy="1762680"/>
+            <a:ext cx="1122694" cy="1938948"/>
           </a:xfrm>
           <a:prstGeom prst="rect">
             <a:avLst/>
@@ -11822,7 +11816,7 @@
                 <a:cs typeface="Calibri"/>
                 <a:sym typeface="Calibri"/>
               </a:rPr>
-              <a:t>$1.50</a:t>
+              <a:t>$2.00</a:t>
             </a:r>
           </a:p>
           <a:p>
@@ -11834,7 +11828,7 @@
                 <a:cs typeface="Calibri"/>
                 <a:sym typeface="Calibri"/>
               </a:rPr>
-              <a:t>$2.00</a:t>
+              <a:t>$1.50</a:t>
             </a:r>
             <a:endParaRPr sz="2700" b="1" dirty="0">
               <a:latin typeface="Calibri"/>
@@ -11976,7 +11970,7 @@
                 <a:cs typeface="Calibri"/>
                 <a:sym typeface="Calibri"/>
               </a:rPr>
-              <a:t>$2.00</a:t>
+              <a:t>$3.00</a:t>
             </a:r>
           </a:p>
           <a:p>
@@ -12000,7 +11994,7 @@
                 <a:cs typeface="Calibri"/>
                 <a:sym typeface="Calibri"/>
               </a:rPr>
-              <a:t>$3.00</a:t>
+              <a:t>$2.00</a:t>
             </a:r>
           </a:p>
           <a:p>

</xml_diff>

<commit_message>
fix: update TournamentMenu assets for improved display
</commit_message>
<xml_diff>
--- a/Assets/Menu/TournamentMenu/TournamentMenu.pptx
+++ b/Assets/Menu/TournamentMenu/TournamentMenu.pptx
@@ -10633,7 +10633,7 @@
         <p:spPr>
           <a:xfrm>
             <a:off x="429119" y="361061"/>
-            <a:ext cx="5595904" cy="6277302"/>
+            <a:ext cx="5595904" cy="6735478"/>
           </a:xfrm>
           <a:prstGeom prst="roundRect">
             <a:avLst>
@@ -11003,7 +11003,7 @@
         <p:spPr>
           <a:xfrm>
             <a:off x="623942" y="1330503"/>
-            <a:ext cx="4038729" cy="5262935"/>
+            <a:ext cx="4038729" cy="5678433"/>
           </a:xfrm>
           <a:prstGeom prst="rect">
             <a:avLst/>
@@ -11060,6 +11060,17 @@
                 <a:sym typeface="Calibri"/>
               </a:rPr>
               <a:t>    + BBQ &amp; Cheese</a:t>
+            </a:r>
+          </a:p>
+          <a:p>
+            <a:r>
+              <a:rPr lang="en-US" sz="2700" b="1" dirty="0">
+                <a:latin typeface="Calibri"/>
+                <a:ea typeface="Calibri"/>
+                <a:cs typeface="Calibri"/>
+                <a:sym typeface="Calibri"/>
+              </a:rPr>
+              <a:t>Walking Tacos</a:t>
             </a:r>
           </a:p>
           <a:p>
@@ -11495,7 +11506,7 @@
         <p:spPr>
           <a:xfrm>
             <a:off x="4523526" y="1330503"/>
-            <a:ext cx="1280708" cy="5262935"/>
+            <a:ext cx="1280708" cy="5678433"/>
           </a:xfrm>
           <a:prstGeom prst="rect">
             <a:avLst/>
@@ -11556,6 +11567,18 @@
                 <a:sym typeface="Calibri"/>
               </a:rPr>
               <a:t>$8.00</a:t>
+            </a:r>
+          </a:p>
+          <a:p>
+            <a:pPr algn="r"/>
+            <a:r>
+              <a:rPr lang="en-US" sz="2700" b="1" dirty="0">
+                <a:latin typeface="Calibri"/>
+                <a:ea typeface="Calibri"/>
+                <a:cs typeface="Calibri"/>
+                <a:sym typeface="Calibri"/>
+              </a:rPr>
+              <a:t>$5.00</a:t>
             </a:r>
           </a:p>
           <a:p>

</xml_diff>